<commit_message>
fix: Replace Unicode chars in eval tests for Windows compatibility, update docs and recommendation agent
- Fix UnicodeEncodeError in eval tests by replacing ★ and — with ASCII equivalents
- Update recommendation agent prompts and tools
- Update project documentation and monitoring docs

Co-Authored-By: Claude Opus 4.6 <noreply@anthropic.com>
</commit_message>
<xml_diff>
--- a/docs/SmartShop_AI_Demo.pptx
+++ b/docs/SmartShop_AI_Demo.pptx
@@ -229,7 +229,7 @@
             <c:multiLvlStrRef>
               <c:f>Sheet1!$A$2:$A$16</c:f>
               <c:multiLvlStrCache>
-                <c:ptCount val="15"/>
+                <c:ptCount val="21"/>
                 <c:lvl>
                   <c:pt idx="0">
                     <c:v>S14</c:v>
@@ -276,6 +276,24 @@
                   <c:pt idx="14">
                     <c:v>S64</c:v>
                   </c:pt>
+                  <c:pt idx="15">
+                    <c:v>S63</c:v>
+                  </c:pt>
+                  <c:pt idx="16">
+                    <c:v>S65</c:v>
+                  </c:pt>
+                  <c:pt idx="17">
+                    <c:v>S66</c:v>
+                  </c:pt>
+                  <c:pt idx="18">
+                    <c:v>S67</c:v>
+                  </c:pt>
+                  <c:pt idx="19">
+                    <c:v>S68</c:v>
+                  </c:pt>
+                  <c:pt idx="20">
+                    <c:v>S69</c:v>
+                  </c:pt>
                 </c:lvl>
               </c:multiLvlStrCache>
             </c:multiLvlStrRef>
@@ -285,7 +303,7 @@
               <c:f>Sheet1!$B$2:$B$16</c:f>
               <c:numCache>
                 <c:formatCode>General</c:formatCode>
-                <c:ptCount val="15"/>
+                <c:ptCount val="21"/>
                 <c:pt idx="0">
                   <c:v>222</c:v>
                 </c:pt>
@@ -330,6 +348,24 @@
                 </c:pt>
                 <c:pt idx="14">
                   <c:v>430</c:v>
+                </c:pt>
+                <c:pt idx="15">
+                  <c:v>444</c:v>
+                </c:pt>
+                <c:pt idx="16">
+                  <c:v>460</c:v>
+                </c:pt>
+                <c:pt idx="17">
+                  <c:v>474</c:v>
+                </c:pt>
+                <c:pt idx="18">
+                  <c:v>486</c:v>
+                </c:pt>
+                <c:pt idx="19">
+                  <c:v>500</c:v>
+                </c:pt>
+                <c:pt idx="20">
+                  <c:v>511</c:v>
                 </c:pt>
               </c:numCache>
             </c:numRef>
@@ -965,7 +1001,7 @@
           <a:p>
             <a:r>
               <a:rPr lang="en-US" dirty="0"/>
-              <a:t>We've addressed key risks. For LLM reliability, we have a circuit breaker pattern with graceful fallback to cached responses. For performance, a dual-backend cache with Redis primary and in-memory fallback. For security, request correlation, structured errors, and Azure Key Vault. And for scalability, Azure Container Apps with auto-scaling and Redis-backed sessions.</a:t>
+              <a:t>We've addressed key risks. For LLM reliability, we have a circuit breaker pattern with graceful fallback to cached responses, plus confidence gating that routes low-confidence classifications to the general agent. For performance, a dual-backend cache with Redis primary and in-memory fallback, plus SQL query optimization combining 3 queries into 1. For security, request correlation, structured errors, DB connectivity monitoring with masked host logging, and Azure Key Vault. And for scalability, Azure Container Apps with auto-scaling and Redis-backed sessions.</a:t>
             </a:r>
             <a:endParaRPr lang="en-US" dirty="0"/>
           </a:p>
@@ -1229,7 +1265,7 @@
           <a:p>
             <a:r>
               <a:rPr lang="en-US" dirty="0"/>
-              <a:t>SmartShop AI is a conversational AI assistant with 5 specialized agents working together. An orchestrator classifies user intent and routes to the right expert agent. Session memory preserves context across the conversation. And it's production-ready with CI/CD, Azure deployment, and 430+ tests.</a:t>
+              <a:t>SmartShop AI is a conversational AI assistant with 5 specialized agents working together. An orchestrator classifies user intent and routes to the right expert agent. Session memory preserves context across the conversation. And it's production-ready with CI/CD, Azure deployment, and 511+ tests.</a:t>
             </a:r>
             <a:endParaRPr lang="en-US" dirty="0"/>
           </a:p>
@@ -1581,7 +1617,7 @@
           <a:p>
             <a:r>
               <a:rPr lang="en-US" dirty="0"/>
-              <a:t>Our tech stack: FastAPI for the high-performance async API. pydantic-ai for type-safe AI agents. GPT-4o-mini as the LLM. FAISS for vector similarity search powering our policy RAG pipeline. PostgreSQL and Redis for data and caching. Azure Container Apps for production hosting. 430+ tests with pytest. And GitHub Actions for the full CI/CD pipeline.</a:t>
+              <a:t>Our tech stack: FastAPI for the high-performance async API. pydantic-ai for type-safe AI agents. GPT-4o-mini as the LLM. FAISS for vector similarity search powering our policy RAG pipeline. PostgreSQL and Redis for data and caching. Azure Container Apps for production hosting. 511+ tests with pytest. And GitHub Actions for the full CI/CD pipeline.</a:t>
             </a:r>
             <a:endParaRPr lang="en-US" dirty="0"/>
           </a:p>
@@ -1669,7 +1705,7 @@
           <a:p>
             <a:r>
               <a:rPr lang="en-US" dirty="0"/>
-              <a:t>Let me share some key metrics. We have 430+ unit tests providing comprehensive coverage. 21 user stories shipped across 4 sprints. 5 specialized AI agents. And sub-200ms average latency. You can see the test count growing steadily — we maintained discipline of adding 10-20 tests per story throughout the project.</a:t>
+              <a:t>Let me share some key metrics. We have 511+ unit tests providing comprehensive coverage. 29 user stories shipped across 5 sprints. 5 specialized AI agents. And sub-200ms average latency. You can see the test count growing steadily — we maintained discipline of adding 10-20 tests per story throughout the project. The final hardening phase added 81 tests focused on logging, DB health, DRY refactoring, SQL optimization, AI routing accuracy, and error handling.</a:t>
             </a:r>
             <a:endParaRPr lang="en-US" dirty="0"/>
           </a:p>
@@ -1757,7 +1793,7 @@
           <a:p>
             <a:r>
               <a:rPr lang="en-US" dirty="0"/>
-              <a:t>Here's our roadmap across 4 phases. Phase 1 built the foundation — catalog, API, agents, UI. Phase 2 added intelligence — orchestrator, session memory, error handling. Phase 3 focused on polish — UI enhancements, inline reviews, product comparison. And Phase 4, where we are now, covers production readiness — CI/CD, Azure deployment, monitoring, and file logging.</a:t>
+              <a:t>Here's our roadmap across 4 phases plus a hardening phase. Phase 1 built the foundation — catalog, API, agents, UI. Phase 2 added intelligence — orchestrator, session memory, error handling. Phase 3 focused on polish — UI enhancements, inline reviews, product comparison. And Phase 4 covers production readiness and hardening — CI/CD, Azure deployment, file logging with rotation, DB health checks, DRY code refactoring, SQL query optimization, AI routing accuracy improvements, and error handling hardening. All phases are now complete with 511+ tests.</a:t>
             </a:r>
             <a:endParaRPr lang="en-US" dirty="0"/>
           </a:p>
@@ -2176,7 +2212,7 @@
       </p:sp>
       <p:pic>
         <p:nvPicPr>
-          <p:cNvPr id="4" name="Image 0" descr="preencoded.png">    </p:cNvPr>
+          <p:cNvPr id="4" name="Image 0" descr="preencoded.png"/>
           <p:cNvPicPr>
             <a:picLocks noChangeAspect="1"/>
           </p:cNvPicPr>
@@ -2484,7 +2520,7 @@
       </p:sp>
       <p:pic>
         <p:nvPicPr>
-          <p:cNvPr id="4" name="Image 0" descr="preencoded.png">    </p:cNvPr>
+          <p:cNvPr id="4" name="Image 0" descr="preencoded.png"/>
           <p:cNvPicPr>
             <a:picLocks noChangeAspect="1"/>
           </p:cNvPicPr>
@@ -2606,7 +2642,7 @@
       </p:sp>
       <p:pic>
         <p:nvPicPr>
-          <p:cNvPr id="8" name="Image 1" descr="preencoded.png">    </p:cNvPr>
+          <p:cNvPr id="8" name="Image 1" descr="preencoded.png"/>
           <p:cNvPicPr>
             <a:picLocks noChangeAspect="1"/>
           </p:cNvPicPr>
@@ -2728,7 +2764,7 @@
       </p:sp>
       <p:pic>
         <p:nvPicPr>
-          <p:cNvPr id="12" name="Image 2" descr="preencoded.png">    </p:cNvPr>
+          <p:cNvPr id="12" name="Image 2" descr="preencoded.png"/>
           <p:cNvPicPr>
             <a:picLocks noChangeAspect="1"/>
           </p:cNvPicPr>
@@ -2850,7 +2886,7 @@
       </p:sp>
       <p:pic>
         <p:nvPicPr>
-          <p:cNvPr id="16" name="Image 3" descr="preencoded.png">    </p:cNvPr>
+          <p:cNvPr id="16" name="Image 3" descr="preencoded.png"/>
           <p:cNvPicPr>
             <a:picLocks noChangeAspect="1"/>
           </p:cNvPicPr>
@@ -3028,7 +3064,7 @@
       </p:sp>
       <p:pic>
         <p:nvPicPr>
-          <p:cNvPr id="4" name="Image 0" descr="preencoded.png">    </p:cNvPr>
+          <p:cNvPr id="4" name="Image 0" descr="preencoded.png"/>
           <p:cNvPicPr>
             <a:picLocks noChangeAspect="1"/>
           </p:cNvPicPr>
@@ -4016,7 +4052,7 @@
       </p:sp>
       <p:pic>
         <p:nvPicPr>
-          <p:cNvPr id="5" name="Image 0" descr="preencoded.png">    </p:cNvPr>
+          <p:cNvPr id="5" name="Image 0" descr="preencoded.png"/>
           <p:cNvPicPr>
             <a:picLocks noChangeAspect="1"/>
           </p:cNvPicPr>
@@ -4138,7 +4174,7 @@
       </p:sp>
       <p:pic>
         <p:nvPicPr>
-          <p:cNvPr id="9" name="Image 1" descr="preencoded.png">    </p:cNvPr>
+          <p:cNvPr id="9" name="Image 1" descr="preencoded.png"/>
           <p:cNvPicPr>
             <a:picLocks noChangeAspect="1"/>
           </p:cNvPicPr>
@@ -4260,7 +4296,7 @@
       </p:sp>
       <p:pic>
         <p:nvPicPr>
-          <p:cNvPr id="13" name="Image 2" descr="preencoded.png">    </p:cNvPr>
+          <p:cNvPr id="13" name="Image 2" descr="preencoded.png"/>
           <p:cNvPicPr>
             <a:picLocks noChangeAspect="1"/>
           </p:cNvPicPr>
@@ -4382,7 +4418,7 @@
       </p:sp>
       <p:pic>
         <p:nvPicPr>
-          <p:cNvPr id="17" name="Image 3" descr="preencoded.png">    </p:cNvPr>
+          <p:cNvPr id="17" name="Image 3" descr="preencoded.png"/>
           <p:cNvPicPr>
             <a:picLocks noChangeAspect="1"/>
           </p:cNvPicPr>
@@ -4575,7 +4611,7 @@
       </p:sp>
       <p:pic>
         <p:nvPicPr>
-          <p:cNvPr id="4" name="Image 0" descr="preencoded.png">    </p:cNvPr>
+          <p:cNvPr id="4" name="Image 0" descr="preencoded.png"/>
           <p:cNvPicPr>
             <a:picLocks noChangeAspect="1"/>
           </p:cNvPicPr>
@@ -4697,7 +4733,7 @@
       </p:sp>
       <p:pic>
         <p:nvPicPr>
-          <p:cNvPr id="8" name="Image 1" descr="preencoded.png">    </p:cNvPr>
+          <p:cNvPr id="8" name="Image 1" descr="preencoded.png"/>
           <p:cNvPicPr>
             <a:picLocks noChangeAspect="1"/>
           </p:cNvPicPr>
@@ -4819,7 +4855,7 @@
       </p:sp>
       <p:pic>
         <p:nvPicPr>
-          <p:cNvPr id="12" name="Image 2" descr="preencoded.png">    </p:cNvPr>
+          <p:cNvPr id="12" name="Image 2" descr="preencoded.png"/>
           <p:cNvPicPr>
             <a:picLocks noChangeAspect="1"/>
           </p:cNvPicPr>
@@ -4941,7 +4977,7 @@
       </p:sp>
       <p:pic>
         <p:nvPicPr>
-          <p:cNvPr id="16" name="Image 3" descr="preencoded.png">    </p:cNvPr>
+          <p:cNvPr id="16" name="Image 3" descr="preencoded.png"/>
           <p:cNvPicPr>
             <a:picLocks noChangeAspect="1"/>
           </p:cNvPicPr>
@@ -5063,7 +5099,7 @@
       </p:sp>
       <p:pic>
         <p:nvPicPr>
-          <p:cNvPr id="20" name="Image 4" descr="preencoded.png">    </p:cNvPr>
+          <p:cNvPr id="20" name="Image 4" descr="preencoded.png"/>
           <p:cNvPicPr>
             <a:picLocks noChangeAspect="1"/>
           </p:cNvPicPr>
@@ -7128,7 +7164,7 @@
       </p:sp>
       <p:pic>
         <p:nvPicPr>
-          <p:cNvPr id="4" name="Image 0" descr="preencoded.png">    </p:cNvPr>
+          <p:cNvPr id="4" name="Image 0" descr="preencoded.png"/>
           <p:cNvPicPr>
             <a:picLocks noChangeAspect="1"/>
           </p:cNvPicPr>
@@ -7252,7 +7288,7 @@
       </p:sp>
       <p:pic>
         <p:nvPicPr>
-          <p:cNvPr id="8" name="Image 1" descr="preencoded.png">    </p:cNvPr>
+          <p:cNvPr id="8" name="Image 1" descr="preencoded.png"/>
           <p:cNvPicPr>
             <a:picLocks noChangeAspect="1"/>
           </p:cNvPicPr>
@@ -7376,7 +7412,7 @@
       </p:sp>
       <p:pic>
         <p:nvPicPr>
-          <p:cNvPr id="12" name="Image 2" descr="preencoded.png">    </p:cNvPr>
+          <p:cNvPr id="12" name="Image 2" descr="preencoded.png"/>
           <p:cNvPicPr>
             <a:picLocks noChangeAspect="1"/>
           </p:cNvPicPr>
@@ -7500,7 +7536,7 @@
       </p:sp>
       <p:pic>
         <p:nvPicPr>
-          <p:cNvPr id="16" name="Image 3" descr="preencoded.png">    </p:cNvPr>
+          <p:cNvPr id="16" name="Image 3" descr="preencoded.png"/>
           <p:cNvPicPr>
             <a:picLocks noChangeAspect="1"/>
           </p:cNvPicPr>
@@ -7624,7 +7660,7 @@
       </p:sp>
       <p:pic>
         <p:nvPicPr>
-          <p:cNvPr id="20" name="Image 4" descr="preencoded.png">    </p:cNvPr>
+          <p:cNvPr id="20" name="Image 4" descr="preencoded.png"/>
           <p:cNvPicPr>
             <a:picLocks noChangeAspect="1"/>
           </p:cNvPicPr>
@@ -7748,7 +7784,7 @@
       </p:sp>
       <p:pic>
         <p:nvPicPr>
-          <p:cNvPr id="24" name="Image 5" descr="preencoded.png">    </p:cNvPr>
+          <p:cNvPr id="24" name="Image 5" descr="preencoded.png"/>
           <p:cNvPicPr>
             <a:picLocks noChangeAspect="1"/>
           </p:cNvPicPr>
@@ -7872,7 +7908,7 @@
       </p:sp>
       <p:pic>
         <p:nvPicPr>
-          <p:cNvPr id="28" name="Image 6" descr="preencoded.png">    </p:cNvPr>
+          <p:cNvPr id="28" name="Image 6" descr="preencoded.png"/>
           <p:cNvPicPr>
             <a:picLocks noChangeAspect="1"/>
           </p:cNvPicPr>
@@ -7927,7 +7963,7 @@
                 <a:ea typeface="Trebuchet MS" pitchFamily="34" charset="-122"/>
                 <a:cs typeface="Trebuchet MS" pitchFamily="34" charset="-120"/>
               </a:rPr>
-              <a:t>430+ Tests</a:t>
+              <a:t>511+ Tests</a:t>
             </a:r>
             <a:endParaRPr lang="en-US" sz="1400" dirty="0"/>
           </a:p>
@@ -7996,7 +8032,7 @@
       </p:sp>
       <p:pic>
         <p:nvPicPr>
-          <p:cNvPr id="32" name="Image 7" descr="preencoded.png">    </p:cNvPr>
+          <p:cNvPr id="32" name="Image 7" descr="preencoded.png"/>
           <p:cNvPicPr>
             <a:picLocks noChangeAspect="1"/>
           </p:cNvPicPr>
@@ -8227,7 +8263,7 @@
                 <a:ea typeface="Trebuchet MS" pitchFamily="34" charset="-122"/>
                 <a:cs typeface="Trebuchet MS" pitchFamily="34" charset="-120"/>
               </a:rPr>
-              <a:t>430+</a:t>
+              <a:t>511+</a:t>
             </a:r>
             <a:endParaRPr lang="en-US" sz="3600" dirty="0"/>
           </a:p>
@@ -8371,7 +8407,7 @@
                 <a:ea typeface="Trebuchet MS" pitchFamily="34" charset="-122"/>
                 <a:cs typeface="Trebuchet MS" pitchFamily="34" charset="-120"/>
               </a:rPr>
-              <a:t>21</a:t>
+              <a:t>29</a:t>
             </a:r>
             <a:endParaRPr lang="en-US" sz="3600" dirty="0"/>
           </a:p>
@@ -8449,7 +8485,7 @@
                 <a:ea typeface="Calibri" pitchFamily="34" charset="-122"/>
                 <a:cs typeface="Calibri" pitchFamily="34" charset="-120"/>
               </a:rPr>
-              <a:t>Completed across 4 sprints</a:t>
+              <a:t>Completed across 5 sprints</a:t>
             </a:r>
             <a:endParaRPr lang="en-US" sz="1000" dirty="0"/>
           </a:p>
@@ -9492,7 +9528,7 @@
             <a:avLst/>
           </a:prstGeom>
           <a:solidFill>
-            <a:srgbClr val="F59E0B"/>
+            <a:srgbClr val="02C39A"/>
           </a:solidFill>
           <a:ln/>
         </p:spPr>
@@ -9524,13 +9560,13 @@
             <a:r>
               <a:rPr lang="en-US" sz="800" b="1" dirty="0">
                 <a:solidFill>
-                  <a:srgbClr val="0B1D2E"/>
+                  <a:srgbClr val="FFFFFF"/>
                 </a:solidFill>
                 <a:latin typeface="Calibri" pitchFamily="34" charset="0"/>
                 <a:ea typeface="Calibri" pitchFamily="34" charset="-122"/>
                 <a:cs typeface="Calibri" pitchFamily="34" charset="-120"/>
               </a:rPr>
-              <a:t>CURRENT</a:t>
+              <a:t>COMPLETE</a:t>
             </a:r>
             <a:endParaRPr lang="en-US" sz="800" dirty="0"/>
           </a:p>
@@ -9569,7 +9605,7 @@
                 <a:ea typeface="Trebuchet MS" pitchFamily="34" charset="-122"/>
                 <a:cs typeface="Trebuchet MS" pitchFamily="34" charset="-120"/>
               </a:rPr>
-              <a:t>Production</a:t>
+              <a:t>Production &amp; Hardening</a:t>
             </a:r>
             <a:endParaRPr lang="en-US" sz="1400" dirty="0"/>
           </a:p>
@@ -9608,7 +9644,7 @@
                 <a:ea typeface="Calibri" pitchFamily="34" charset="-122"/>
                 <a:cs typeface="Calibri" pitchFamily="34" charset="-120"/>
               </a:rPr>
-              <a:t>CI/CD pipeline, Azure deployment, file logging, monitoring</a:t>
+              <a:t>CI/CD, Azure, logging, DB health, DRY refactor, SQL optimization, AI routing, error hardening</a:t>
             </a:r>
             <a:endParaRPr lang="en-US" sz="1000" dirty="0"/>
           </a:p>

</xml_diff>